<commit_message>
Embed project screenshots into video presentation
Co-authored-by: Cursor <cursoragent@cursor.com>
</commit_message>
<xml_diff>
--- a/report/VIDEO_PRESENTATION.pptx
+++ b/report/VIDEO_PRESENTATION.pptx
@@ -516,7 +516,7 @@
           <a:lstStyle/>
           <a:p>
             <a:r>
-              <a:t>Introduce yourself, assignment name, and repository link. State the goal: build and deploy a heart disease prediction API.</a:t>
+              <a:t>Introduce yourself, assignment name, and repository link.</a:t>
             </a:r>
           </a:p>
         </p:txBody>
@@ -1076,7 +1076,7 @@
           <a:lstStyle/>
           <a:p>
             <a:r>
-              <a:t>Show project folders and mention Python 3.12 requirement.</a:t>
+              <a:t>Show project folders live and mention Python 3.12 requirement.</a:t>
             </a:r>
           </a:p>
         </p:txBody>
@@ -4809,61 +4809,54 @@
           </a:p>
         </p:txBody>
       </p:sp>
-      <p:sp>
-        <p:nvSpPr>
-          <p:cNvPr id="5" name="Rectangle 4"/>
-          <p:cNvSpPr/>
+      <p:pic>
+        <p:nvPicPr>
+          <p:cNvPr id="5" name="Picture 4" descr="docker_run.png"/>
+          <p:cNvPicPr>
+            <a:picLocks noChangeAspect="1"/>
+          </p:cNvPicPr>
           <p:nvPr/>
-        </p:nvSpPr>
-        <p:spPr>
-          <a:xfrm>
-            <a:off x="4663440" y="1234440"/>
-            <a:ext cx="4023360" cy="4389120"/>
+        </p:nvPicPr>
+        <p:blipFill>
+          <a:blip r:embed="rId2"/>
+          <a:stretch>
+            <a:fillRect/>
+          </a:stretch>
+        </p:blipFill>
+        <p:spPr>
+          <a:xfrm>
+            <a:off x="4572000" y="1234440"/>
+            <a:ext cx="4114800" cy="2249424"/>
           </a:xfrm>
           <a:prstGeom prst="rect">
             <a:avLst/>
           </a:prstGeom>
-          <a:solidFill>
-            <a:srgbClr val="F0F5FA"/>
-          </a:solidFill>
-          <a:ln w="19050">
-            <a:solidFill>
-              <a:srgbClr val="006699"/>
-            </a:solidFill>
-          </a:ln>
-        </p:spPr>
-        <p:style>
-          <a:lnRef idx="1">
-            <a:schemeClr val="accent1"/>
-          </a:lnRef>
-          <a:fillRef idx="3">
-            <a:schemeClr val="accent1"/>
-          </a:fillRef>
-          <a:effectRef idx="2">
-            <a:schemeClr val="accent1"/>
-          </a:effectRef>
-          <a:fontRef idx="minor">
-            <a:schemeClr val="lt1"/>
-          </a:fontRef>
-        </p:style>
-        <p:txBody>
-          <a:bodyPr rtlCol="0" anchor="ctr"/>
-          <a:lstStyle/>
-          <a:p>
-            <a:pPr algn="ctr"/>
-            <a:r>
-              <a:rPr sz="1400" b="1">
-                <a:solidFill>
-                  <a:srgbClr val="006699"/>
-                </a:solidFill>
-                <a:latin typeface="Calibri"/>
-              </a:rPr>
-              <a:t>Insert Screenshot
-docker build / docker run / predict response</a:t>
-            </a:r>
-          </a:p>
-        </p:txBody>
-      </p:sp>
+        </p:spPr>
+      </p:pic>
+      <p:pic>
+        <p:nvPicPr>
+          <p:cNvPr id="6" name="Picture 5" descr="03_curl_predict_success.png"/>
+          <p:cNvPicPr>
+            <a:picLocks noChangeAspect="1"/>
+          </p:cNvPicPr>
+          <p:nvPr/>
+        </p:nvPicPr>
+        <p:blipFill>
+          <a:blip r:embed="rId3"/>
+          <a:stretch>
+            <a:fillRect/>
+          </a:stretch>
+        </p:blipFill>
+        <p:spPr>
+          <a:xfrm>
+            <a:off x="4572000" y="3557016"/>
+            <a:ext cx="4114800" cy="2249424"/>
+          </a:xfrm>
+          <a:prstGeom prst="rect">
+            <a:avLst/>
+          </a:prstGeom>
+        </p:spPr>
+      </p:pic>
     </p:spTree>
   </p:cSld>
   <p:clrMapOvr>
@@ -5053,61 +5046,78 @@
           </a:p>
         </p:txBody>
       </p:sp>
-      <p:sp>
-        <p:nvSpPr>
-          <p:cNvPr id="5" name="Rectangle 4"/>
-          <p:cNvSpPr/>
+      <p:pic>
+        <p:nvPicPr>
+          <p:cNvPr id="5" name="Picture 4" descr="minicube start success.png"/>
+          <p:cNvPicPr>
+            <a:picLocks noChangeAspect="1"/>
+          </p:cNvPicPr>
           <p:nvPr/>
-        </p:nvSpPr>
-        <p:spPr>
-          <a:xfrm>
-            <a:off x="4663440" y="1234440"/>
-            <a:ext cx="4023360" cy="4389120"/>
+        </p:nvPicPr>
+        <p:blipFill>
+          <a:blip r:embed="rId2"/>
+          <a:stretch>
+            <a:fillRect/>
+          </a:stretch>
+        </p:blipFill>
+        <p:spPr>
+          <a:xfrm>
+            <a:off x="4572000" y="1234440"/>
+            <a:ext cx="4114800" cy="1475232"/>
           </a:xfrm>
           <a:prstGeom prst="rect">
             <a:avLst/>
           </a:prstGeom>
-          <a:solidFill>
-            <a:srgbClr val="F0F5FA"/>
-          </a:solidFill>
-          <a:ln w="19050">
-            <a:solidFill>
-              <a:srgbClr val="006699"/>
-            </a:solidFill>
-          </a:ln>
-        </p:spPr>
-        <p:style>
-          <a:lnRef idx="1">
-            <a:schemeClr val="accent1"/>
-          </a:lnRef>
-          <a:fillRef idx="3">
-            <a:schemeClr val="accent1"/>
-          </a:fillRef>
-          <a:effectRef idx="2">
-            <a:schemeClr val="accent1"/>
-          </a:effectRef>
-          <a:fontRef idx="minor">
-            <a:schemeClr val="lt1"/>
-          </a:fontRef>
-        </p:style>
-        <p:txBody>
-          <a:bodyPr rtlCol="0" anchor="ctr"/>
-          <a:lstStyle/>
-          <a:p>
-            <a:pPr algn="ctr"/>
-            <a:r>
-              <a:rPr sz="1400" b="1">
-                <a:solidFill>
-                  <a:srgbClr val="006699"/>
-                </a:solidFill>
-                <a:latin typeface="Calibri"/>
-              </a:rPr>
-              <a:t>Insert Screenshot
-kubectl get pods / get svc / health check</a:t>
-            </a:r>
-          </a:p>
-        </p:txBody>
-      </p:sp>
+        </p:spPr>
+      </p:pic>
+      <p:pic>
+        <p:nvPicPr>
+          <p:cNvPr id="6" name="Picture 5" descr="k8s deployment.png"/>
+          <p:cNvPicPr>
+            <a:picLocks noChangeAspect="1"/>
+          </p:cNvPicPr>
+          <p:nvPr/>
+        </p:nvPicPr>
+        <p:blipFill>
+          <a:blip r:embed="rId3"/>
+          <a:stretch>
+            <a:fillRect/>
+          </a:stretch>
+        </p:blipFill>
+        <p:spPr>
+          <a:xfrm>
+            <a:off x="4572000" y="2782824"/>
+            <a:ext cx="4114800" cy="1475232"/>
+          </a:xfrm>
+          <a:prstGeom prst="rect">
+            <a:avLst/>
+          </a:prstGeom>
+        </p:spPr>
+      </p:pic>
+      <p:pic>
+        <p:nvPicPr>
+          <p:cNvPr id="7" name="Picture 6" descr="k8s health success.png"/>
+          <p:cNvPicPr>
+            <a:picLocks noChangeAspect="1"/>
+          </p:cNvPicPr>
+          <p:nvPr/>
+        </p:nvPicPr>
+        <p:blipFill>
+          <a:blip r:embed="rId4"/>
+          <a:stretch>
+            <a:fillRect/>
+          </a:stretch>
+        </p:blipFill>
+        <p:spPr>
+          <a:xfrm>
+            <a:off x="4572000" y="4331208"/>
+            <a:ext cx="4114800" cy="1475232"/>
+          </a:xfrm>
+          <a:prstGeom prst="rect">
+            <a:avLst/>
+          </a:prstGeom>
+        </p:spPr>
+      </p:pic>
     </p:spTree>
   </p:cSld>
   <p:clrMapOvr>
@@ -5297,61 +5307,54 @@
           </a:p>
         </p:txBody>
       </p:sp>
-      <p:sp>
-        <p:nvSpPr>
-          <p:cNvPr id="5" name="Rectangle 4"/>
-          <p:cNvSpPr/>
+      <p:pic>
+        <p:nvPicPr>
+          <p:cNvPr id="5" name="Picture 4" descr="Request logs.png"/>
+          <p:cNvPicPr>
+            <a:picLocks noChangeAspect="1"/>
+          </p:cNvPicPr>
           <p:nvPr/>
-        </p:nvSpPr>
-        <p:spPr>
-          <a:xfrm>
-            <a:off x="4663440" y="1234440"/>
-            <a:ext cx="4023360" cy="4389120"/>
+        </p:nvPicPr>
+        <p:blipFill>
+          <a:blip r:embed="rId2"/>
+          <a:stretch>
+            <a:fillRect/>
+          </a:stretch>
+        </p:blipFill>
+        <p:spPr>
+          <a:xfrm>
+            <a:off x="4572000" y="1234440"/>
+            <a:ext cx="4114800" cy="2249424"/>
           </a:xfrm>
           <a:prstGeom prst="rect">
             <a:avLst/>
           </a:prstGeom>
-          <a:solidFill>
-            <a:srgbClr val="F0F5FA"/>
-          </a:solidFill>
-          <a:ln w="19050">
-            <a:solidFill>
-              <a:srgbClr val="006699"/>
-            </a:solidFill>
-          </a:ln>
-        </p:spPr>
-        <p:style>
-          <a:lnRef idx="1">
-            <a:schemeClr val="accent1"/>
-          </a:lnRef>
-          <a:fillRef idx="3">
-            <a:schemeClr val="accent1"/>
-          </a:fillRef>
-          <a:effectRef idx="2">
-            <a:schemeClr val="accent1"/>
-          </a:effectRef>
-          <a:fontRef idx="minor">
-            <a:schemeClr val="lt1"/>
-          </a:fontRef>
-        </p:style>
-        <p:txBody>
-          <a:bodyPr rtlCol="0" anchor="ctr"/>
-          <a:lstStyle/>
-          <a:p>
-            <a:pPr algn="ctr"/>
-            <a:r>
-              <a:rPr sz="1400" b="1">
-                <a:solidFill>
-                  <a:srgbClr val="006699"/>
-                </a:solidFill>
-                <a:latin typeface="Calibri"/>
-              </a:rPr>
-              <a:t>Insert Screenshot
-Request logs + /metrics output</a:t>
-            </a:r>
-          </a:p>
-        </p:txBody>
-      </p:sp>
+        </p:spPr>
+      </p:pic>
+      <p:pic>
+        <p:nvPicPr>
+          <p:cNvPr id="6" name="Picture 5" descr="metrics endpoint.png"/>
+          <p:cNvPicPr>
+            <a:picLocks noChangeAspect="1"/>
+          </p:cNvPicPr>
+          <p:nvPr/>
+        </p:nvPicPr>
+        <p:blipFill>
+          <a:blip r:embed="rId3"/>
+          <a:stretch>
+            <a:fillRect/>
+          </a:stretch>
+        </p:blipFill>
+        <p:spPr>
+          <a:xfrm>
+            <a:off x="4572000" y="3557016"/>
+            <a:ext cx="4114800" cy="2249424"/>
+          </a:xfrm>
+          <a:prstGeom prst="rect">
+            <a:avLst/>
+          </a:prstGeom>
+        </p:spPr>
+      </p:pic>
     </p:spTree>
   </p:cSld>
   <p:clrMapOvr>
@@ -5447,7 +5450,7 @@
         <p:spPr>
           <a:xfrm>
             <a:off x="548640" y="1280160"/>
-            <a:ext cx="4389120" cy="4572000"/>
+            <a:ext cx="4114800" cy="4572000"/>
           </a:xfrm>
           <a:prstGeom prst="rect">
             <a:avLst/>
@@ -5483,61 +5486,54 @@
           </a:p>
         </p:txBody>
       </p:sp>
-      <p:sp>
-        <p:nvSpPr>
-          <p:cNvPr id="5" name="Rectangle 4"/>
-          <p:cNvSpPr/>
+      <p:pic>
+        <p:nvPicPr>
+          <p:cNvPr id="5" name="Picture 4" descr="01_experiments_page.png"/>
+          <p:cNvPicPr>
+            <a:picLocks noChangeAspect="1"/>
+          </p:cNvPicPr>
           <p:nvPr/>
-        </p:nvSpPr>
-        <p:spPr>
-          <a:xfrm>
-            <a:off x="4937760" y="1280160"/>
-            <a:ext cx="3657600" cy="4572000"/>
+        </p:nvPicPr>
+        <p:blipFill>
+          <a:blip r:embed="rId2"/>
+          <a:stretch>
+            <a:fillRect/>
+          </a:stretch>
+        </p:blipFill>
+        <p:spPr>
+          <a:xfrm>
+            <a:off x="4754880" y="1280160"/>
+            <a:ext cx="3931920" cy="2249424"/>
           </a:xfrm>
           <a:prstGeom prst="rect">
             <a:avLst/>
           </a:prstGeom>
-          <a:solidFill>
-            <a:srgbClr val="F0F5FA"/>
-          </a:solidFill>
-          <a:ln w="19050">
-            <a:solidFill>
-              <a:srgbClr val="006699"/>
-            </a:solidFill>
-          </a:ln>
-        </p:spPr>
-        <p:style>
-          <a:lnRef idx="1">
-            <a:schemeClr val="accent1"/>
-          </a:lnRef>
-          <a:fillRef idx="3">
-            <a:schemeClr val="accent1"/>
-          </a:fillRef>
-          <a:effectRef idx="2">
-            <a:schemeClr val="accent1"/>
-          </a:effectRef>
-          <a:fontRef idx="minor">
-            <a:schemeClr val="lt1"/>
-          </a:fontRef>
-        </p:style>
-        <p:txBody>
-          <a:bodyPr rtlCol="0" anchor="ctr"/>
-          <a:lstStyle/>
-          <a:p>
-            <a:pPr algn="ctr"/>
-            <a:r>
-              <a:rPr sz="1400" b="1">
-                <a:solidFill>
-                  <a:srgbClr val="006699"/>
-                </a:solidFill>
-                <a:latin typeface="Calibri"/>
-              </a:rPr>
-              <a:t>Insert Screenshot
-Optional: architecture diagram or repo tree</a:t>
-            </a:r>
-          </a:p>
-        </p:txBody>
-      </p:sp>
+        </p:spPr>
+      </p:pic>
+      <p:pic>
+        <p:nvPicPr>
+          <p:cNvPr id="6" name="Picture 5" descr="k8s deployment.png"/>
+          <p:cNvPicPr>
+            <a:picLocks noChangeAspect="1"/>
+          </p:cNvPicPr>
+          <p:nvPr/>
+        </p:nvPicPr>
+        <p:blipFill>
+          <a:blip r:embed="rId3"/>
+          <a:stretch>
+            <a:fillRect/>
+          </a:stretch>
+        </p:blipFill>
+        <p:spPr>
+          <a:xfrm>
+            <a:off x="4754880" y="3602736"/>
+            <a:ext cx="3931920" cy="2249424"/>
+          </a:xfrm>
+          <a:prstGeom prst="rect">
+            <a:avLst/>
+          </a:prstGeom>
+        </p:spPr>
+      </p:pic>
     </p:spTree>
   </p:cSld>
   <p:clrMapOvr>
@@ -6306,61 +6302,30 @@
           </a:p>
         </p:txBody>
       </p:sp>
-      <p:sp>
-        <p:nvSpPr>
-          <p:cNvPr id="5" name="Rectangle 4"/>
-          <p:cNvSpPr/>
+      <p:pic>
+        <p:nvPicPr>
+          <p:cNvPr id="5" name="Picture 4" descr="01_experiments_page.png"/>
+          <p:cNvPicPr>
+            <a:picLocks noChangeAspect="1"/>
+          </p:cNvPicPr>
           <p:nvPr/>
-        </p:nvSpPr>
-        <p:spPr>
-          <a:xfrm>
-            <a:off x="4663440" y="1234440"/>
-            <a:ext cx="4023360" cy="4389120"/>
+        </p:nvPicPr>
+        <p:blipFill>
+          <a:blip r:embed="rId2"/>
+          <a:stretch>
+            <a:fillRect/>
+          </a:stretch>
+        </p:blipFill>
+        <p:spPr>
+          <a:xfrm>
+            <a:off x="4572000" y="1234440"/>
+            <a:ext cx="4114800" cy="4572000"/>
           </a:xfrm>
           <a:prstGeom prst="rect">
             <a:avLst/>
           </a:prstGeom>
-          <a:solidFill>
-            <a:srgbClr val="F0F5FA"/>
-          </a:solidFill>
-          <a:ln w="19050">
-            <a:solidFill>
-              <a:srgbClr val="006699"/>
-            </a:solidFill>
-          </a:ln>
-        </p:spPr>
-        <p:style>
-          <a:lnRef idx="1">
-            <a:schemeClr val="accent1"/>
-          </a:lnRef>
-          <a:fillRef idx="3">
-            <a:schemeClr val="accent1"/>
-          </a:fillRef>
-          <a:effectRef idx="2">
-            <a:schemeClr val="accent1"/>
-          </a:effectRef>
-          <a:fontRef idx="minor">
-            <a:schemeClr val="lt1"/>
-          </a:fontRef>
-        </p:style>
-        <p:txBody>
-          <a:bodyPr rtlCol="0" anchor="ctr"/>
-          <a:lstStyle/>
-          <a:p>
-            <a:pPr algn="ctr"/>
-            <a:r>
-              <a:rPr sz="1400" b="1">
-                <a:solidFill>
-                  <a:srgbClr val="006699"/>
-                </a:solidFill>
-                <a:latin typeface="Calibri"/>
-              </a:rPr>
-              <a:t>Insert Screenshot
-VS Code project tree or README</a:t>
-            </a:r>
-          </a:p>
-        </p:txBody>
-      </p:sp>
+        </p:spPr>
+      </p:pic>
     </p:spTree>
   </p:cSld>
   <p:clrMapOvr>
@@ -6550,61 +6515,78 @@
           </a:p>
         </p:txBody>
       </p:sp>
-      <p:sp>
-        <p:nvSpPr>
-          <p:cNvPr id="5" name="Rectangle 4"/>
-          <p:cNvSpPr/>
+      <p:pic>
+        <p:nvPicPr>
+          <p:cNvPr id="5" name="Picture 4" descr="class_balance.png"/>
+          <p:cNvPicPr>
+            <a:picLocks noChangeAspect="1"/>
+          </p:cNvPicPr>
           <p:nvPr/>
-        </p:nvSpPr>
-        <p:spPr>
-          <a:xfrm>
-            <a:off x="4663440" y="1234440"/>
-            <a:ext cx="4023360" cy="4389120"/>
+        </p:nvPicPr>
+        <p:blipFill>
+          <a:blip r:embed="rId2"/>
+          <a:stretch>
+            <a:fillRect/>
+          </a:stretch>
+        </p:blipFill>
+        <p:spPr>
+          <a:xfrm>
+            <a:off x="4572000" y="1234440"/>
+            <a:ext cx="4114800" cy="1475232"/>
           </a:xfrm>
           <a:prstGeom prst="rect">
             <a:avLst/>
           </a:prstGeom>
-          <a:solidFill>
-            <a:srgbClr val="F0F5FA"/>
-          </a:solidFill>
-          <a:ln w="19050">
-            <a:solidFill>
-              <a:srgbClr val="006699"/>
-            </a:solidFill>
-          </a:ln>
-        </p:spPr>
-        <p:style>
-          <a:lnRef idx="1">
-            <a:schemeClr val="accent1"/>
-          </a:lnRef>
-          <a:fillRef idx="3">
-            <a:schemeClr val="accent1"/>
-          </a:fillRef>
-          <a:effectRef idx="2">
-            <a:schemeClr val="accent1"/>
-          </a:effectRef>
-          <a:fontRef idx="minor">
-            <a:schemeClr val="lt1"/>
-          </a:fontRef>
-        </p:style>
-        <p:txBody>
-          <a:bodyPr rtlCol="0" anchor="ctr"/>
-          <a:lstStyle/>
-          <a:p>
-            <a:pPr algn="ctr"/>
-            <a:r>
-              <a:rPr sz="1400" b="1">
-                <a:solidFill>
-                  <a:srgbClr val="006699"/>
-                </a:solidFill>
-                <a:latin typeface="Calibri"/>
-              </a:rPr>
-              <a:t>Insert Screenshot
-class_balance.png / histograms / heatmap</a:t>
-            </a:r>
-          </a:p>
-        </p:txBody>
-      </p:sp>
+        </p:spPr>
+      </p:pic>
+      <p:pic>
+        <p:nvPicPr>
+          <p:cNvPr id="6" name="Picture 5" descr="numeric_feature_histograms.png"/>
+          <p:cNvPicPr>
+            <a:picLocks noChangeAspect="1"/>
+          </p:cNvPicPr>
+          <p:nvPr/>
+        </p:nvPicPr>
+        <p:blipFill>
+          <a:blip r:embed="rId3"/>
+          <a:stretch>
+            <a:fillRect/>
+          </a:stretch>
+        </p:blipFill>
+        <p:spPr>
+          <a:xfrm>
+            <a:off x="4572000" y="2782824"/>
+            <a:ext cx="4114800" cy="1475232"/>
+          </a:xfrm>
+          <a:prstGeom prst="rect">
+            <a:avLst/>
+          </a:prstGeom>
+        </p:spPr>
+      </p:pic>
+      <p:pic>
+        <p:nvPicPr>
+          <p:cNvPr id="7" name="Picture 6" descr="correlation_heatmap.png"/>
+          <p:cNvPicPr>
+            <a:picLocks noChangeAspect="1"/>
+          </p:cNvPicPr>
+          <p:nvPr/>
+        </p:nvPicPr>
+        <p:blipFill>
+          <a:blip r:embed="rId4"/>
+          <a:stretch>
+            <a:fillRect/>
+          </a:stretch>
+        </p:blipFill>
+        <p:spPr>
+          <a:xfrm>
+            <a:off x="4572000" y="4331208"/>
+            <a:ext cx="4114800" cy="1475232"/>
+          </a:xfrm>
+          <a:prstGeom prst="rect">
+            <a:avLst/>
+          </a:prstGeom>
+        </p:spPr>
+      </p:pic>
     </p:spTree>
   </p:cSld>
   <p:clrMapOvr>
@@ -6794,61 +6776,30 @@
           </a:p>
         </p:txBody>
       </p:sp>
-      <p:sp>
-        <p:nvSpPr>
-          <p:cNvPr id="5" name="Rectangle 4"/>
-          <p:cNvSpPr/>
+      <p:pic>
+        <p:nvPicPr>
+          <p:cNvPr id="5" name="Picture 4" descr="02_run_training_table.png"/>
+          <p:cNvPicPr>
+            <a:picLocks noChangeAspect="1"/>
+          </p:cNvPicPr>
           <p:nvPr/>
-        </p:nvSpPr>
-        <p:spPr>
-          <a:xfrm>
-            <a:off x="4663440" y="1234440"/>
-            <a:ext cx="4023360" cy="4389120"/>
+        </p:nvPicPr>
+        <p:blipFill>
+          <a:blip r:embed="rId2"/>
+          <a:stretch>
+            <a:fillRect/>
+          </a:stretch>
+        </p:blipFill>
+        <p:spPr>
+          <a:xfrm>
+            <a:off x="4572000" y="1234440"/>
+            <a:ext cx="4114800" cy="4572000"/>
           </a:xfrm>
           <a:prstGeom prst="rect">
             <a:avLst/>
           </a:prstGeom>
-          <a:solidFill>
-            <a:srgbClr val="F0F5FA"/>
-          </a:solidFill>
-          <a:ln w="19050">
-            <a:solidFill>
-              <a:srgbClr val="006699"/>
-            </a:solidFill>
-          </a:ln>
-        </p:spPr>
-        <p:style>
-          <a:lnRef idx="1">
-            <a:schemeClr val="accent1"/>
-          </a:lnRef>
-          <a:fillRef idx="3">
-            <a:schemeClr val="accent1"/>
-          </a:fillRef>
-          <a:effectRef idx="2">
-            <a:schemeClr val="accent1"/>
-          </a:effectRef>
-          <a:fontRef idx="minor">
-            <a:schemeClr val="lt1"/>
-          </a:fontRef>
-        </p:style>
-        <p:txBody>
-          <a:bodyPr rtlCol="0" anchor="ctr"/>
-          <a:lstStyle/>
-          <a:p>
-            <a:pPr algn="ctr"/>
-            <a:r>
-              <a:rPr sz="1400" b="1">
-                <a:solidFill>
-                  <a:srgbClr val="006699"/>
-                </a:solidFill>
-                <a:latin typeface="Calibri"/>
-              </a:rPr>
-              <a:t>Insert Screenshot
-model_cv_metrics.csv</a:t>
-            </a:r>
-          </a:p>
-        </p:txBody>
-      </p:sp>
+        </p:spPr>
+      </p:pic>
     </p:spTree>
   </p:cSld>
   <p:clrMapOvr>
@@ -6944,8 +6895,8 @@
           <p:nvPr/>
         </p:nvGraphicFramePr>
         <p:xfrm>
-          <a:off x="548640" y="1371600"/>
-          <a:ext cx="8046720" cy="1371600"/>
+          <a:off x="457200" y="1280160"/>
+          <a:ext cx="4206240" cy="1188720"/>
         </p:xfrm>
         <a:graphic>
           <a:graphicData uri="http://schemas.openxmlformats.org/drawingml/2006/table">
@@ -6954,20 +6905,20 @@
                 <a:tableStyleId>{5C22544A-7EE6-4342-B048-85BDC9FD1C3A}</a:tableStyleId>
               </a:tblPr>
               <a:tblGrid>
-                <a:gridCol w="1609344"/>
-                <a:gridCol w="1609344"/>
-                <a:gridCol w="1609344"/>
-                <a:gridCol w="1609344"/>
-                <a:gridCol w="1609344"/>
+                <a:gridCol w="841248"/>
+                <a:gridCol w="841248"/>
+                <a:gridCol w="841248"/>
+                <a:gridCol w="841248"/>
+                <a:gridCol w="841248"/>
               </a:tblGrid>
-              <a:tr h="457200">
+              <a:tr h="396240">
                 <a:tc>
                   <a:txBody>
                     <a:bodyPr/>
                     <a:lstStyle/>
                     <a:p>
                       <a:r>
-                        <a:rPr sz="1400" b="1">
+                        <a:rPr sz="1200" b="1">
                           <a:solidFill>
                             <a:srgbClr val="FFFFFF"/>
                           </a:solidFill>
@@ -6989,7 +6940,7 @@
                     <a:lstStyle/>
                     <a:p>
                       <a:r>
-                        <a:rPr sz="1400" b="1">
+                        <a:rPr sz="1200" b="1">
                           <a:solidFill>
                             <a:srgbClr val="FFFFFF"/>
                           </a:solidFill>
@@ -7011,7 +6962,7 @@
                     <a:lstStyle/>
                     <a:p>
                       <a:r>
-                        <a:rPr sz="1400" b="1">
+                        <a:rPr sz="1200" b="1">
                           <a:solidFill>
                             <a:srgbClr val="FFFFFF"/>
                           </a:solidFill>
@@ -7033,7 +6984,7 @@
                     <a:lstStyle/>
                     <a:p>
                       <a:r>
-                        <a:rPr sz="1400" b="1">
+                        <a:rPr sz="1200" b="1">
                           <a:solidFill>
                             <a:srgbClr val="FFFFFF"/>
                           </a:solidFill>
@@ -7055,7 +7006,7 @@
                     <a:lstStyle/>
                     <a:p>
                       <a:r>
-                        <a:rPr sz="1400" b="1">
+                        <a:rPr sz="1200" b="1">
                           <a:solidFill>
                             <a:srgbClr val="FFFFFF"/>
                           </a:solidFill>
@@ -7072,14 +7023,14 @@
                   </a:tcPr>
                 </a:tc>
               </a:tr>
-              <a:tr h="457200">
+              <a:tr h="396240">
                 <a:tc>
                   <a:txBody>
                     <a:bodyPr/>
                     <a:lstStyle/>
                     <a:p>
                       <a:r>
-                        <a:rPr sz="1400" b="1">
+                        <a:rPr sz="1200" b="1">
                           <a:solidFill>
                             <a:srgbClr val="282828"/>
                           </a:solidFill>
@@ -7097,7 +7048,7 @@
                     <a:lstStyle/>
                     <a:p>
                       <a:r>
-                        <a:rPr sz="1400" b="0">
+                        <a:rPr sz="1200" b="0">
                           <a:solidFill>
                             <a:srgbClr val="282828"/>
                           </a:solidFill>
@@ -7115,7 +7066,7 @@
                     <a:lstStyle/>
                     <a:p>
                       <a:r>
-                        <a:rPr sz="1400" b="0">
+                        <a:rPr sz="1200" b="0">
                           <a:solidFill>
                             <a:srgbClr val="282828"/>
                           </a:solidFill>
@@ -7133,7 +7084,7 @@
                     <a:lstStyle/>
                     <a:p>
                       <a:r>
-                        <a:rPr sz="1400" b="0">
+                        <a:rPr sz="1200" b="0">
                           <a:solidFill>
                             <a:srgbClr val="282828"/>
                           </a:solidFill>
@@ -7151,7 +7102,7 @@
                     <a:lstStyle/>
                     <a:p>
                       <a:r>
-                        <a:rPr sz="1400" b="0">
+                        <a:rPr sz="1200" b="0">
                           <a:solidFill>
                             <a:srgbClr val="282828"/>
                           </a:solidFill>
@@ -7164,14 +7115,14 @@
                   <a:tcPr/>
                 </a:tc>
               </a:tr>
-              <a:tr h="457200">
+              <a:tr h="396240">
                 <a:tc>
                   <a:txBody>
                     <a:bodyPr/>
                     <a:lstStyle/>
                     <a:p>
                       <a:r>
-                        <a:rPr sz="1400" b="1">
+                        <a:rPr sz="1200" b="1">
                           <a:solidFill>
                             <a:srgbClr val="282828"/>
                           </a:solidFill>
@@ -7189,7 +7140,7 @@
                     <a:lstStyle/>
                     <a:p>
                       <a:r>
-                        <a:rPr sz="1400" b="0">
+                        <a:rPr sz="1200" b="0">
                           <a:solidFill>
                             <a:srgbClr val="282828"/>
                           </a:solidFill>
@@ -7207,7 +7158,7 @@
                     <a:lstStyle/>
                     <a:p>
                       <a:r>
-                        <a:rPr sz="1400" b="0">
+                        <a:rPr sz="1200" b="0">
                           <a:solidFill>
                             <a:srgbClr val="282828"/>
                           </a:solidFill>
@@ -7225,7 +7176,7 @@
                     <a:lstStyle/>
                     <a:p>
                       <a:r>
-                        <a:rPr sz="1400" b="0">
+                        <a:rPr sz="1200" b="0">
                           <a:solidFill>
                             <a:srgbClr val="282828"/>
                           </a:solidFill>
@@ -7243,7 +7194,7 @@
                     <a:lstStyle/>
                     <a:p>
                       <a:r>
-                        <a:rPr sz="1400" b="0">
+                        <a:rPr sz="1200" b="0">
                           <a:solidFill>
                             <a:srgbClr val="282828"/>
                           </a:solidFill>
@@ -7268,8 +7219,8 @@
         </p:nvSpPr>
         <p:spPr>
           <a:xfrm>
-            <a:off x="548640" y="3108960"/>
-            <a:ext cx="8046720" cy="2286000"/>
+            <a:off x="457200" y="2743200"/>
+            <a:ext cx="4206240" cy="2011680"/>
           </a:xfrm>
           <a:prstGeom prst="rect">
             <a:avLst/>
@@ -7326,7 +7277,7 @@
                 </a:solidFill>
                 <a:latin typeface="Calibri"/>
               </a:rPr>
-              <a:t>Random Forest had slightly higher recall, but gap is small</a:t>
+              <a:t>Random Forest had slightly higher recall</a:t>
             </a:r>
           </a:p>
           <a:p>
@@ -7347,6 +7298,54 @@
           </a:p>
         </p:txBody>
       </p:sp>
+      <p:pic>
+        <p:nvPicPr>
+          <p:cNvPr id="6" name="Picture 5" descr="02_run_logreg_table.png"/>
+          <p:cNvPicPr>
+            <a:picLocks noChangeAspect="1"/>
+          </p:cNvPicPr>
+          <p:nvPr/>
+        </p:nvPicPr>
+        <p:blipFill>
+          <a:blip r:embed="rId2"/>
+          <a:stretch>
+            <a:fillRect/>
+          </a:stretch>
+        </p:blipFill>
+        <p:spPr>
+          <a:xfrm>
+            <a:off x="4754880" y="1280160"/>
+            <a:ext cx="3931920" cy="2249424"/>
+          </a:xfrm>
+          <a:prstGeom prst="rect">
+            <a:avLst/>
+          </a:prstGeom>
+        </p:spPr>
+      </p:pic>
+      <p:pic>
+        <p:nvPicPr>
+          <p:cNvPr id="7" name="Picture 6" descr="04_logistic_artifacts.png"/>
+          <p:cNvPicPr>
+            <a:picLocks noChangeAspect="1"/>
+          </p:cNvPicPr>
+          <p:nvPr/>
+        </p:nvPicPr>
+        <p:blipFill>
+          <a:blip r:embed="rId3"/>
+          <a:stretch>
+            <a:fillRect/>
+          </a:stretch>
+        </p:blipFill>
+        <p:spPr>
+          <a:xfrm>
+            <a:off x="4754880" y="3602736"/>
+            <a:ext cx="3931920" cy="2249424"/>
+          </a:xfrm>
+          <a:prstGeom prst="rect">
+            <a:avLst/>
+          </a:prstGeom>
+        </p:spPr>
+      </p:pic>
     </p:spTree>
   </p:cSld>
   <p:clrMapOvr>
@@ -7536,61 +7535,54 @@
           </a:p>
         </p:txBody>
       </p:sp>
-      <p:sp>
-        <p:nvSpPr>
-          <p:cNvPr id="5" name="Rectangle 4"/>
-          <p:cNvSpPr/>
+      <p:pic>
+        <p:nvPicPr>
+          <p:cNvPr id="5" name="Picture 4" descr="01_experiments_page.png"/>
+          <p:cNvPicPr>
+            <a:picLocks noChangeAspect="1"/>
+          </p:cNvPicPr>
           <p:nvPr/>
-        </p:nvSpPr>
-        <p:spPr>
-          <a:xfrm>
-            <a:off x="4663440" y="1234440"/>
-            <a:ext cx="4023360" cy="4389120"/>
+        </p:nvPicPr>
+        <p:blipFill>
+          <a:blip r:embed="rId2"/>
+          <a:stretch>
+            <a:fillRect/>
+          </a:stretch>
+        </p:blipFill>
+        <p:spPr>
+          <a:xfrm>
+            <a:off x="4572000" y="1234440"/>
+            <a:ext cx="4114800" cy="2249424"/>
           </a:xfrm>
           <a:prstGeom prst="rect">
             <a:avLst/>
           </a:prstGeom>
-          <a:solidFill>
-            <a:srgbClr val="F0F5FA"/>
-          </a:solidFill>
-          <a:ln w="19050">
-            <a:solidFill>
-              <a:srgbClr val="006699"/>
-            </a:solidFill>
-          </a:ln>
-        </p:spPr>
-        <p:style>
-          <a:lnRef idx="1">
-            <a:schemeClr val="accent1"/>
-          </a:lnRef>
-          <a:fillRef idx="3">
-            <a:schemeClr val="accent1"/>
-          </a:fillRef>
-          <a:effectRef idx="2">
-            <a:schemeClr val="accent1"/>
-          </a:effectRef>
-          <a:fontRef idx="minor">
-            <a:schemeClr val="lt1"/>
-          </a:fontRef>
-        </p:style>
-        <p:txBody>
-          <a:bodyPr rtlCol="0" anchor="ctr"/>
-          <a:lstStyle/>
-          <a:p>
-            <a:pPr algn="ctr"/>
-            <a:r>
-              <a:rPr sz="1400" b="1">
-                <a:solidFill>
-                  <a:srgbClr val="006699"/>
-                </a:solidFill>
-                <a:latin typeface="Calibri"/>
-              </a:rPr>
-              <a:t>Insert Screenshot
-MLflow experiments / runs / artifacts</a:t>
-            </a:r>
-          </a:p>
-        </p:txBody>
-      </p:sp>
+        </p:spPr>
+      </p:pic>
+      <p:pic>
+        <p:nvPicPr>
+          <p:cNvPr id="6" name="Picture 5" descr="02_run_training_table.png"/>
+          <p:cNvPicPr>
+            <a:picLocks noChangeAspect="1"/>
+          </p:cNvPicPr>
+          <p:nvPr/>
+        </p:nvPicPr>
+        <p:blipFill>
+          <a:blip r:embed="rId3"/>
+          <a:stretch>
+            <a:fillRect/>
+          </a:stretch>
+        </p:blipFill>
+        <p:spPr>
+          <a:xfrm>
+            <a:off x="4572000" y="3557016"/>
+            <a:ext cx="4114800" cy="2249424"/>
+          </a:xfrm>
+          <a:prstGeom prst="rect">
+            <a:avLst/>
+          </a:prstGeom>
+        </p:spPr>
+      </p:pic>
     </p:spTree>
   </p:cSld>
   <p:clrMapOvr>
@@ -7780,61 +7772,30 @@
           </a:p>
         </p:txBody>
       </p:sp>
-      <p:sp>
-        <p:nvSpPr>
-          <p:cNvPr id="5" name="Rectangle 4"/>
-          <p:cNvSpPr/>
+      <p:pic>
+        <p:nvPicPr>
+          <p:cNvPr id="5" name="Picture 4" descr="04_logistic_artifacts.png"/>
+          <p:cNvPicPr>
+            <a:picLocks noChangeAspect="1"/>
+          </p:cNvPicPr>
           <p:nvPr/>
-        </p:nvSpPr>
-        <p:spPr>
-          <a:xfrm>
-            <a:off x="4663440" y="1234440"/>
-            <a:ext cx="4023360" cy="4389120"/>
+        </p:nvPicPr>
+        <p:blipFill>
+          <a:blip r:embed="rId2"/>
+          <a:stretch>
+            <a:fillRect/>
+          </a:stretch>
+        </p:blipFill>
+        <p:spPr>
+          <a:xfrm>
+            <a:off x="4572000" y="1234440"/>
+            <a:ext cx="4114800" cy="4572000"/>
           </a:xfrm>
           <a:prstGeom prst="rect">
             <a:avLst/>
           </a:prstGeom>
-          <a:solidFill>
-            <a:srgbClr val="F0F5FA"/>
-          </a:solidFill>
-          <a:ln w="19050">
-            <a:solidFill>
-              <a:srgbClr val="006699"/>
-            </a:solidFill>
-          </a:ln>
-        </p:spPr>
-        <p:style>
-          <a:lnRef idx="1">
-            <a:schemeClr val="accent1"/>
-          </a:lnRef>
-          <a:fillRef idx="3">
-            <a:schemeClr val="accent1"/>
-          </a:fillRef>
-          <a:effectRef idx="2">
-            <a:schemeClr val="accent1"/>
-          </a:effectRef>
-          <a:fontRef idx="minor">
-            <a:schemeClr val="lt1"/>
-          </a:fontRef>
-        </p:style>
-        <p:txBody>
-          <a:bodyPr rtlCol="0" anchor="ctr"/>
-          <a:lstStyle/>
-          <a:p>
-            <a:pPr algn="ctr"/>
-            <a:r>
-              <a:rPr sz="1400" b="1">
-                <a:solidFill>
-                  <a:srgbClr val="006699"/>
-                </a:solidFill>
-                <a:latin typeface="Calibri"/>
-              </a:rPr>
-              <a:t>Insert Screenshot
-models/ folder contents</a:t>
-            </a:r>
-          </a:p>
-        </p:txBody>
-      </p:sp>
+        </p:spPr>
+      </p:pic>
     </p:spTree>
   </p:cSld>
   <p:clrMapOvr>
@@ -8024,61 +7985,30 @@
           </a:p>
         </p:txBody>
       </p:sp>
-      <p:sp>
-        <p:nvSpPr>
-          <p:cNvPr id="5" name="Rectangle 4"/>
-          <p:cNvSpPr/>
+      <p:pic>
+        <p:nvPicPr>
+          <p:cNvPr id="5" name="Picture 4" descr="Screenshot 2026-07-11 214818.png"/>
+          <p:cNvPicPr>
+            <a:picLocks noChangeAspect="1"/>
+          </p:cNvPicPr>
           <p:nvPr/>
-        </p:nvSpPr>
-        <p:spPr>
-          <a:xfrm>
-            <a:off x="4663440" y="1234440"/>
-            <a:ext cx="4023360" cy="4389120"/>
+        </p:nvPicPr>
+        <p:blipFill>
+          <a:blip r:embed="rId2"/>
+          <a:stretch>
+            <a:fillRect/>
+          </a:stretch>
+        </p:blipFill>
+        <p:spPr>
+          <a:xfrm>
+            <a:off x="4572000" y="1234440"/>
+            <a:ext cx="4114800" cy="4572000"/>
           </a:xfrm>
           <a:prstGeom prst="rect">
             <a:avLst/>
           </a:prstGeom>
-          <a:solidFill>
-            <a:srgbClr val="F0F5FA"/>
-          </a:solidFill>
-          <a:ln w="19050">
-            <a:solidFill>
-              <a:srgbClr val="006699"/>
-            </a:solidFill>
-          </a:ln>
-        </p:spPr>
-        <p:style>
-          <a:lnRef idx="1">
-            <a:schemeClr val="accent1"/>
-          </a:lnRef>
-          <a:fillRef idx="3">
-            <a:schemeClr val="accent1"/>
-          </a:fillRef>
-          <a:effectRef idx="2">
-            <a:schemeClr val="accent1"/>
-          </a:effectRef>
-          <a:fontRef idx="minor">
-            <a:schemeClr val="lt1"/>
-          </a:fontRef>
-        </p:style>
-        <p:txBody>
-          <a:bodyPr rtlCol="0" anchor="ctr"/>
-          <a:lstStyle/>
-          <a:p>
-            <a:pPr algn="ctr"/>
-            <a:r>
-              <a:rPr sz="1400" b="1">
-                <a:solidFill>
-                  <a:srgbClr val="006699"/>
-                </a:solidFill>
-                <a:latin typeface="Calibri"/>
-              </a:rPr>
-              <a:t>Insert Screenshot
-GitHub Actions green workflow</a:t>
-            </a:r>
-          </a:p>
-        </p:txBody>
-      </p:sp>
+        </p:spPr>
+      </p:pic>
     </p:spTree>
   </p:cSld>
   <p:clrMapOvr>

</xml_diff>